<commit_message>
Templates: US spelling throughout
</commit_message>
<xml_diff>
--- a/brand/bolt-creative-client-proposal.pptx
+++ b/brand/bolt-creative-client-proposal.pptx
@@ -113,33 +113,33 @@
   <p:extLst>
     <p:ext uri="{521415D9-36F7-43E2-AB2F-B90AF26B5E84}">
       <p14:sectionLst xmlns:p14="http://schemas.microsoft.com/office/powerpoint/2010/main">
-        <p14:section name="Cover" id="{71763371-6a64-837d-550c-f43c8268bd73}">
+        <p14:section name="Cover" id="{b7ea4a55-823b-a47e-49a8-61f054d8cde8}">
           <p14:sldIdLst>
             <p14:sldId id="256"/>
           </p14:sldIdLst>
         </p14:section>
-        <p14:section name="Understanding" id="{b5e60b61-53b8-9fd8-2652-de7adac5b54c}">
+        <p14:section name="Understanding" id="{50923cb0-f46c-14a2-3dac-784c074b8fe4}">
           <p14:sldIdLst>
             <p14:sldId id="257"/>
             <p14:sldId id="258"/>
           </p14:sldIdLst>
         </p14:section>
-        <p14:section name="Approach" id="{d7f18ba8-d47f-43bc-3669-f7f98f0d63dc}">
+        <p14:section name="Approach" id="{66965321-75f6-2c76-0461-f5f0de66e630}">
           <p14:sldIdLst>
             <p14:sldId id="259"/>
           </p14:sldIdLst>
         </p14:section>
-        <p14:section name="Proof" id="{b9e02fd9-0e04-4811-dd1e-53242f4aa30d}">
+        <p14:section name="Proof" id="{55a93d2b-5a9c-4796-5b57-61b459105324}">
           <p14:sldIdLst>
             <p14:sldId id="260"/>
           </p14:sldIdLst>
         </p14:section>
-        <p14:section name="Commercials" id="{ab5e62e0-75e9-9ce7-78d9-cc90521ab2be}">
+        <p14:section name="Commercials" id="{d9a07376-a590-6b9b-c5c4-b5db71d418a6}">
           <p14:sldIdLst>
             <p14:sldId id="261"/>
           </p14:sldIdLst>
         </p14:section>
-        <p14:section name="Close" id="{a4c8b438-7248-3263-2926-2b56a517ed20}">
+        <p14:section name="Close" id="{4be77963-443c-5254-e525-857d75f88678}">
           <p14:sldIdLst>
             <p14:sldId id="262"/>
           </p14:sldIdLst>
@@ -2725,7 +2725,7 @@
                   <a:srgbClr val="6F6A5D"/>
                 </a:solidFill>
               </a:rPr>
-              <a:t>Say it back in their words. If they do not recognise it, the rest of the deck does not land.</a:t>
+              <a:t>Say it back in their words. If they do not recognize it, the rest of the deck does not land.</a:t>
             </a:r>
             <a:endParaRPr lang="en-US" sz="1250" dirty="0"/>
           </a:p>

</xml_diff>